<commit_message>
feat: update SLIDE_FIREBASE_CLOUD_DMS.pptx with new content
</commit_message>
<xml_diff>
--- a/SLIDE_FIREBASE_CLOUD_DMS.pptx
+++ b/SLIDE_FIREBASE_CLOUD_DMS.pptx
@@ -2167,7 +2167,7 @@
           </a:prstGeom>
           <a:extLst>
             <a:ext uri="{C572A759-6A51-4108-AA02-DFA0A04FC94B}">
-              <ma14:wrappingTextBoxFlag xmlns:ma14="http://schemas.microsoft.com/office/mac/drawingml/2011/main" xmlns="" val="0"/>
+              <ma14:wrappingTextBoxFlag xmlns="" xmlns:ma14="http://schemas.microsoft.com/office/mac/drawingml/2011/main" val="0"/>
             </a:ext>
           </a:extLst>
         </p:spPr>
@@ -2407,7 +2407,7 @@
           </a:prstGeom>
           <a:extLst>
             <a:ext uri="{C572A759-6A51-4108-AA02-DFA0A04FC94B}">
-              <ma14:wrappingTextBoxFlag xmlns:ma14="http://schemas.microsoft.com/office/mac/drawingml/2011/main" xmlns="" val="0"/>
+              <ma14:wrappingTextBoxFlag xmlns="" xmlns:ma14="http://schemas.microsoft.com/office/mac/drawingml/2011/main" val="0"/>
             </a:ext>
           </a:extLst>
         </p:spPr>
@@ -2647,7 +2647,7 @@
           </a:prstGeom>
           <a:extLst>
             <a:ext uri="{C572A759-6A51-4108-AA02-DFA0A04FC94B}">
-              <ma14:wrappingTextBoxFlag xmlns:ma14="http://schemas.microsoft.com/office/mac/drawingml/2011/main" xmlns="" val="0"/>
+              <ma14:wrappingTextBoxFlag xmlns="" xmlns:ma14="http://schemas.microsoft.com/office/mac/drawingml/2011/main" val="0"/>
             </a:ext>
           </a:extLst>
         </p:spPr>
@@ -2887,7 +2887,7 @@
           </a:prstGeom>
           <a:extLst>
             <a:ext uri="{C572A759-6A51-4108-AA02-DFA0A04FC94B}">
-              <ma14:wrappingTextBoxFlag xmlns:ma14="http://schemas.microsoft.com/office/mac/drawingml/2011/main" xmlns="" val="0"/>
+              <ma14:wrappingTextBoxFlag xmlns="" xmlns:ma14="http://schemas.microsoft.com/office/mac/drawingml/2011/main" val="0"/>
             </a:ext>
           </a:extLst>
         </p:spPr>
@@ -3127,7 +3127,7 @@
           </a:prstGeom>
           <a:extLst>
             <a:ext uri="{C572A759-6A51-4108-AA02-DFA0A04FC94B}">
-              <ma14:wrappingTextBoxFlag xmlns:ma14="http://schemas.microsoft.com/office/mac/drawingml/2011/main" xmlns="" val="0"/>
+              <ma14:wrappingTextBoxFlag xmlns="" xmlns:ma14="http://schemas.microsoft.com/office/mac/drawingml/2011/main" val="0"/>
             </a:ext>
           </a:extLst>
         </p:spPr>
@@ -3367,7 +3367,7 @@
           </a:prstGeom>
           <a:extLst>
             <a:ext uri="{C572A759-6A51-4108-AA02-DFA0A04FC94B}">
-              <ma14:wrappingTextBoxFlag xmlns:ma14="http://schemas.microsoft.com/office/mac/drawingml/2011/main" xmlns="" val="0"/>
+              <ma14:wrappingTextBoxFlag xmlns="" xmlns:ma14="http://schemas.microsoft.com/office/mac/drawingml/2011/main" val="0"/>
             </a:ext>
           </a:extLst>
         </p:spPr>
@@ -3442,7 +3442,7 @@
           </a:prstGeom>
           <a:extLst>
             <a:ext uri="{C572A759-6A51-4108-AA02-DFA0A04FC94B}">
-              <ma14:wrappingTextBoxFlag xmlns:ma14="http://schemas.microsoft.com/office/mac/drawingml/2011/main" xmlns="" val="0"/>
+              <ma14:wrappingTextBoxFlag xmlns="" xmlns:ma14="http://schemas.microsoft.com/office/mac/drawingml/2011/main" val="0"/>
             </a:ext>
           </a:extLst>
         </p:spPr>
@@ -3763,7 +3763,7 @@
         <p:spPr>
           <a:xfrm>
             <a:off x="571500" y="1371600"/>
-            <a:ext cx="7086600" cy="1485900"/>
+            <a:ext cx="7281582" cy="1485900"/>
           </a:xfrm>
           <a:prstGeom prst="rect">
             <a:avLst/>
@@ -3775,38 +3775,31 @@
           <a:bodyPr wrap="square" lIns="0" tIns="0" rIns="0" bIns="0" rtlCol="0" anchor="ctr"/>
           <a:lstStyle/>
           <a:p>
-            <a:pPr marL="0" indent="0">
-              <a:buNone/>
-            </a:pPr>
-            <a:r>
-              <a:rPr lang="en-US" sz="4200" b="1" dirty="0">
-                <a:solidFill>
-                  <a:schemeClr val="bg1"/>
-                </a:solidFill>
-                <a:latin typeface="+mj-lt" pitchFamily="34" charset="0"/>
-                <a:ea typeface="+mj-lt" pitchFamily="34" charset="-122"/>
-                <a:cs typeface="+mj-lt" pitchFamily="34" charset="-120"/>
-              </a:rPr>
-              <a:t>StudyDoc Manager |</a:t>
-            </a:r>
-            <a:endParaRPr lang="en-US" sz="4200" dirty="0"/>
-          </a:p>
-          <a:p>
-            <a:pPr marL="0" indent="0">
-              <a:buNone/>
-            </a:pPr>
-            <a:r>
-              <a:rPr lang="en-US" sz="4200" b="1" dirty="0">
-                <a:solidFill>
-                  <a:schemeClr val="bg1"/>
-                </a:solidFill>
-                <a:latin typeface="+mj-lt" pitchFamily="34" charset="0"/>
-                <a:ea typeface="+mj-lt" pitchFamily="34" charset="-122"/>
-                <a:cs typeface="+mj-lt" pitchFamily="34" charset="-120"/>
-              </a:rPr>
-              <a:t>Bài tập tích hợp Cloud</a:t>
-            </a:r>
-            <a:endParaRPr lang="en-US" sz="4200" dirty="0"/>
+            <a:pPr algn="l"/>
+            <a:r>
+              <a:rPr lang="vi-VN" i="0" dirty="0">
+                <a:effectLst/>
+                <a:latin typeface="Cambria" panose="02040503050406030204" pitchFamily="18" charset="0"/>
+                <a:ea typeface="Cambria" panose="02040503050406030204" pitchFamily="18" charset="0"/>
+              </a:rPr>
+              <a:t>Phân tích và Lập phương án tích hợp </a:t>
+            </a:r>
+            <a:r>
+              <a:rPr lang="vi-VN" i="0" dirty="0" err="1">
+                <a:effectLst/>
+                <a:latin typeface="Cambria" panose="02040503050406030204" pitchFamily="18" charset="0"/>
+                <a:ea typeface="Cambria" panose="02040503050406030204" pitchFamily="18" charset="0"/>
+              </a:rPr>
+              <a:t>Cloud</a:t>
+            </a:r>
+            <a:r>
+              <a:rPr lang="vi-VN" i="0" dirty="0">
+                <a:effectLst/>
+                <a:latin typeface="Cambria" panose="02040503050406030204" pitchFamily="18" charset="0"/>
+                <a:ea typeface="Cambria" panose="02040503050406030204" pitchFamily="18" charset="0"/>
+              </a:rPr>
+              <a:t> cho Hệ thống Quản lý Tài liệu</a:t>
+            </a:r>
           </a:p>
         </p:txBody>
       </p:sp>
@@ -4506,7 +4499,7 @@
           </a:prstGeom>
           <a:extLst>
             <a:ext uri="{C572A759-6A51-4108-AA02-DFA0A04FC94B}">
-              <ma14:wrappingTextBoxFlag xmlns:ma14="http://schemas.microsoft.com/office/mac/drawingml/2011/main" xmlns="" val="0"/>
+              <ma14:wrappingTextBoxFlag xmlns="" xmlns:ma14="http://schemas.microsoft.com/office/mac/drawingml/2011/main" val="0"/>
             </a:ext>
           </a:extLst>
         </p:spPr>
@@ -5127,7 +5120,7 @@
           </a:prstGeom>
           <a:extLst>
             <a:ext uri="{C572A759-6A51-4108-AA02-DFA0A04FC94B}">
-              <ma14:wrappingTextBoxFlag xmlns:ma14="http://schemas.microsoft.com/office/mac/drawingml/2011/main" xmlns="" val="0"/>
+              <ma14:wrappingTextBoxFlag xmlns="" xmlns:ma14="http://schemas.microsoft.com/office/mac/drawingml/2011/main" val="0"/>
             </a:ext>
           </a:extLst>
         </p:spPr>
@@ -5935,7 +5928,7 @@
           </a:prstGeom>
           <a:extLst>
             <a:ext uri="{C572A759-6A51-4108-AA02-DFA0A04FC94B}">
-              <ma14:wrappingTextBoxFlag xmlns:ma14="http://schemas.microsoft.com/office/mac/drawingml/2011/main" xmlns="" val="0"/>
+              <ma14:wrappingTextBoxFlag xmlns="" xmlns:ma14="http://schemas.microsoft.com/office/mac/drawingml/2011/main" val="0"/>
             </a:ext>
           </a:extLst>
         </p:spPr>
@@ -6578,7 +6571,7 @@
           </a:prstGeom>
           <a:extLst>
             <a:ext uri="{C572A759-6A51-4108-AA02-DFA0A04FC94B}">
-              <ma14:wrappingTextBoxFlag xmlns:ma14="http://schemas.microsoft.com/office/mac/drawingml/2011/main" xmlns="" val="0"/>
+              <ma14:wrappingTextBoxFlag xmlns="" xmlns:ma14="http://schemas.microsoft.com/office/mac/drawingml/2011/main" val="0"/>
             </a:ext>
           </a:extLst>
         </p:spPr>
@@ -7208,7 +7201,7 @@
           </a:prstGeom>
           <a:extLst>
             <a:ext uri="{C572A759-6A51-4108-AA02-DFA0A04FC94B}">
-              <ma14:wrappingTextBoxFlag xmlns:ma14="http://schemas.microsoft.com/office/mac/drawingml/2011/main" xmlns="" val="0"/>
+              <ma14:wrappingTextBoxFlag xmlns="" xmlns:ma14="http://schemas.microsoft.com/office/mac/drawingml/2011/main" val="0"/>
             </a:ext>
           </a:extLst>
         </p:spPr>
@@ -7343,46 +7336,6 @@
       </p:sp>
       <p:sp>
         <p:nvSpPr>
-          <p:cNvPr id="4" name="Text 0"/>
-          <p:cNvSpPr>
-            <a:spLocks noGrp="1"/>
-          </p:cNvSpPr>
-          <p:nvPr>
-            <p:ph type="body" idx="102" hasCustomPrompt="1"/>
-          </p:nvPr>
-        </p:nvSpPr>
-        <p:spPr>
-          <a:xfrm>
-            <a:off x="571500" y="1600200"/>
-            <a:ext cx="11087100" cy="342900"/>
-          </a:xfrm>
-          <a:prstGeom prst="rect">
-            <a:avLst/>
-          </a:prstGeom>
-          <a:noFill/>
-          <a:ln/>
-        </p:spPr>
-        <p:txBody>
-          <a:bodyPr wrap="square" lIns="0" tIns="0" rIns="0" bIns="0" rtlCol="0" anchor="ctr"/>
-          <a:lstStyle/>
-          <a:p>
-            <a:pPr marL="0" indent="0">
-              <a:buNone/>
-            </a:pPr>
-            <a:r>
-              <a:rPr lang="en-US" sz="1800" dirty="0">
-                <a:solidFill>
-                  <a:schemeClr val="tx2"/>
-                </a:solidFill>
-              </a:rPr>
-              <a:t>Dùng thông tin thật do nhóm tạo; không bịa tên nhóm, project ID hoặc ảnh Console</a:t>
-            </a:r>
-            <a:endParaRPr lang="en-US" sz="1800" dirty="0"/>
-          </a:p>
-        </p:txBody>
-      </p:sp>
-      <p:sp>
-        <p:nvSpPr>
           <p:cNvPr id="7" name="Content panel 249"/>
           <p:cNvSpPr/>
           <p:nvPr/>
@@ -8187,7 +8140,7 @@
           </a:prstGeom>
           <a:extLst>
             <a:ext uri="{C572A759-6A51-4108-AA02-DFA0A04FC94B}">
-              <ma14:wrappingTextBoxFlag xmlns:ma14="http://schemas.microsoft.com/office/mac/drawingml/2011/main" xmlns="" val="0"/>
+              <ma14:wrappingTextBoxFlag xmlns="" xmlns:ma14="http://schemas.microsoft.com/office/mac/drawingml/2011/main" val="0"/>
             </a:ext>
           </a:extLst>
         </p:spPr>
@@ -8322,46 +8275,6 @@
       </p:sp>
       <p:sp>
         <p:nvSpPr>
-          <p:cNvPr id="4" name="Text 0"/>
-          <p:cNvSpPr>
-            <a:spLocks noGrp="1"/>
-          </p:cNvSpPr>
-          <p:nvPr>
-            <p:ph type="body" idx="102" hasCustomPrompt="1"/>
-          </p:nvPr>
-        </p:nvSpPr>
-        <p:spPr>
-          <a:xfrm>
-            <a:off x="571500" y="1600200"/>
-            <a:ext cx="11087100" cy="342900"/>
-          </a:xfrm>
-          <a:prstGeom prst="rect">
-            <a:avLst/>
-          </a:prstGeom>
-          <a:noFill/>
-          <a:ln/>
-        </p:spPr>
-        <p:txBody>
-          <a:bodyPr wrap="square" lIns="0" tIns="0" rIns="0" bIns="0" rtlCol="0" anchor="ctr"/>
-          <a:lstStyle/>
-          <a:p>
-            <a:pPr marL="0" indent="0">
-              <a:buNone/>
-            </a:pPr>
-            <a:r>
-              <a:rPr lang="en-US" sz="1800" dirty="0">
-                <a:solidFill>
-                  <a:schemeClr val="tx2"/>
-                </a:solidFill>
-              </a:rPr>
-              <a:t>Chạy từ thư mục repo; project ID và bucket phải lấy từ cấu hình thật của nhóm</a:t>
-            </a:r>
-            <a:endParaRPr lang="en-US" sz="1800" dirty="0"/>
-          </a:p>
-        </p:txBody>
-      </p:sp>
-      <p:sp>
-        <p:nvSpPr>
           <p:cNvPr id="7" name="Content panel 268"/>
           <p:cNvSpPr/>
           <p:nvPr/>
@@ -9072,7 +8985,7 @@
           </a:prstGeom>
           <a:extLst>
             <a:ext uri="{C572A759-6A51-4108-AA02-DFA0A04FC94B}">
-              <ma14:wrappingTextBoxFlag xmlns:ma14="http://schemas.microsoft.com/office/mac/drawingml/2011/main" xmlns="" val="0"/>
+              <ma14:wrappingTextBoxFlag xmlns="" xmlns:ma14="http://schemas.microsoft.com/office/mac/drawingml/2011/main" val="0"/>
             </a:ext>
           </a:extLst>
         </p:spPr>
@@ -9207,46 +9120,6 @@
       </p:sp>
       <p:sp>
         <p:nvSpPr>
-          <p:cNvPr id="4" name="Text 0"/>
-          <p:cNvSpPr>
-            <a:spLocks noGrp="1"/>
-          </p:cNvSpPr>
-          <p:nvPr>
-            <p:ph type="body" idx="102" hasCustomPrompt="1"/>
-          </p:nvPr>
-        </p:nvSpPr>
-        <p:spPr>
-          <a:xfrm>
-            <a:off x="571500" y="1600200"/>
-            <a:ext cx="11087100" cy="342900"/>
-          </a:xfrm>
-          <a:prstGeom prst="rect">
-            <a:avLst/>
-          </a:prstGeom>
-          <a:noFill/>
-          <a:ln/>
-        </p:spPr>
-        <p:txBody>
-          <a:bodyPr wrap="square" lIns="0" tIns="0" rIns="0" bIns="0" rtlCol="0" anchor="ctr"/>
-          <a:lstStyle/>
-          <a:p>
-            <a:pPr marL="0" indent="0">
-              <a:buNone/>
-            </a:pPr>
-            <a:r>
-              <a:rPr lang="en-US" sz="1800" dirty="0">
-                <a:solidFill>
-                  <a:schemeClr val="tx2"/>
-                </a:solidFill>
-              </a:rPr>
-              <a:t>Checklist cần ghi nhận, không phải kết quả đã chạy hoặc ảnh tài khoản giả</a:t>
-            </a:r>
-            <a:endParaRPr lang="en-US" sz="1800" dirty="0"/>
-          </a:p>
-        </p:txBody>
-      </p:sp>
-      <p:sp>
-        <p:nvSpPr>
           <p:cNvPr id="6" name="Content panel 284"/>
           <p:cNvSpPr/>
           <p:nvPr/>
@@ -10033,48 +9906,6 @@
       </p:sp>
       <p:sp>
         <p:nvSpPr>
-          <p:cNvPr id="24" name="Text 302: Chỉ đánh dấu hoàn tất sau khi lưu bằng chứng thật của từng bước."/>
-          <p:cNvSpPr txBox="1"/>
-          <p:nvPr/>
-        </p:nvSpPr>
-        <p:spPr>
-          <a:xfrm>
-            <a:off x="571500" y="5829300"/>
-            <a:ext cx="11087100" cy="342900"/>
-          </a:xfrm>
-          <a:prstGeom prst="rect">
-            <a:avLst/>
-          </a:prstGeom>
-          <a:noFill/>
-          <a:ln/>
-        </p:spPr>
-        <p:txBody>
-          <a:bodyPr wrap="square" lIns="0" tIns="0" rIns="0" bIns="0" rtlCol="0" anchor="t"/>
-          <a:lstStyle/>
-          <a:p>
-            <a:pPr marL="0" indent="0">
-              <a:lnSpc>
-                <a:spcPct val="106000"/>
-              </a:lnSpc>
-              <a:buNone/>
-            </a:pPr>
-            <a:r>
-              <a:rPr lang="en-US" sz="1800" b="1" dirty="0">
-                <a:solidFill>
-                  <a:schemeClr val="tx1"/>
-                </a:solidFill>
-                <a:latin typeface="+mn-lt" pitchFamily="34" charset="0"/>
-                <a:ea typeface="+mn-lt" pitchFamily="34" charset="-122"/>
-                <a:cs typeface="+mn-lt" pitchFamily="34" charset="-120"/>
-              </a:rPr>
-              <a:t>Chỉ đánh dấu hoàn tất sau khi lưu bằng chứng thật của từng bước.</a:t>
-            </a:r>
-            <a:endParaRPr lang="en-US" sz="1800" dirty="0"/>
-          </a:p>
-        </p:txBody>
-      </p:sp>
-      <p:sp>
-        <p:nvSpPr>
           <p:cNvPr id="25" name="Slide Number Placeholder 0"/>
           <p:cNvSpPr>
             <a:spLocks noGrp="1"/>
@@ -10093,7 +9924,7 @@
           </a:prstGeom>
           <a:extLst>
             <a:ext uri="{C572A759-6A51-4108-AA02-DFA0A04FC94B}">
-              <ma14:wrappingTextBoxFlag xmlns:ma14="http://schemas.microsoft.com/office/mac/drawingml/2011/main" xmlns="" val="0"/>
+              <ma14:wrappingTextBoxFlag xmlns="" xmlns:ma14="http://schemas.microsoft.com/office/mac/drawingml/2011/main" val="0"/>
             </a:ext>
           </a:extLst>
         </p:spPr>
@@ -10228,46 +10059,6 @@
       </p:sp>
       <p:sp>
         <p:nvSpPr>
-          <p:cNvPr id="4" name="Text 0"/>
-          <p:cNvSpPr>
-            <a:spLocks noGrp="1"/>
-          </p:cNvSpPr>
-          <p:nvPr>
-            <p:ph type="body" idx="102" hasCustomPrompt="1"/>
-          </p:nvPr>
-        </p:nvSpPr>
-        <p:spPr>
-          <a:xfrm>
-            <a:off x="571500" y="1600200"/>
-            <a:ext cx="11087100" cy="342900"/>
-          </a:xfrm>
-          <a:prstGeom prst="rect">
-            <a:avLst/>
-          </a:prstGeom>
-          <a:noFill/>
-          <a:ln/>
-        </p:spPr>
-        <p:txBody>
-          <a:bodyPr wrap="square" lIns="0" tIns="0" rIns="0" bIns="0" rtlCol="0" anchor="ctr"/>
-          <a:lstStyle/>
-          <a:p>
-            <a:pPr marL="0" indent="0">
-              <a:buNone/>
-            </a:pPr>
-            <a:r>
-              <a:rPr lang="en-US" sz="1800" dirty="0">
-                <a:solidFill>
-                  <a:schemeClr val="accent6"/>
-                </a:solidFill>
-              </a:rPr>
-              <a:t>Không đánh đồng “có mã triển khai” với “đã nghiệm thu Google / Cloud thật”</a:t>
-            </a:r>
-            <a:endParaRPr lang="en-US" sz="1800" dirty="0"/>
-          </a:p>
-        </p:txBody>
-      </p:sp>
-      <p:sp>
-        <p:nvSpPr>
           <p:cNvPr id="6" name="Content panel 303"/>
           <p:cNvSpPr/>
           <p:nvPr/>
@@ -10697,7 +10488,7 @@
           </a:prstGeom>
           <a:extLst>
             <a:ext uri="{C572A759-6A51-4108-AA02-DFA0A04FC94B}">
-              <ma14:wrappingTextBoxFlag xmlns:ma14="http://schemas.microsoft.com/office/mac/drawingml/2011/main" xmlns="" val="0"/>
+              <ma14:wrappingTextBoxFlag xmlns="" xmlns:ma14="http://schemas.microsoft.com/office/mac/drawingml/2011/main" val="0"/>
             </a:ext>
           </a:extLst>
         </p:spPr>
@@ -12296,7 +12087,7 @@
           </a:prstGeom>
           <a:extLst>
             <a:ext uri="{C572A759-6A51-4108-AA02-DFA0A04FC94B}">
-              <ma14:wrappingTextBoxFlag xmlns:ma14="http://schemas.microsoft.com/office/mac/drawingml/2011/main" xmlns="" val="0"/>
+              <ma14:wrappingTextBoxFlag xmlns="" xmlns:ma14="http://schemas.microsoft.com/office/mac/drawingml/2011/main" val="0"/>
             </a:ext>
           </a:extLst>
         </p:spPr>
@@ -13055,7 +12846,7 @@
           </a:prstGeom>
           <a:extLst>
             <a:ext uri="{C572A759-6A51-4108-AA02-DFA0A04FC94B}">
-              <ma14:wrappingTextBoxFlag xmlns:ma14="http://schemas.microsoft.com/office/mac/drawingml/2011/main" xmlns="" val="0"/>
+              <ma14:wrappingTextBoxFlag xmlns="" xmlns:ma14="http://schemas.microsoft.com/office/mac/drawingml/2011/main" val="0"/>
             </a:ext>
           </a:extLst>
         </p:spPr>
@@ -14073,7 +13864,7 @@
           </a:prstGeom>
           <a:extLst>
             <a:ext uri="{C572A759-6A51-4108-AA02-DFA0A04FC94B}">
-              <ma14:wrappingTextBoxFlag xmlns:ma14="http://schemas.microsoft.com/office/mac/drawingml/2011/main" xmlns="" val="0"/>
+              <ma14:wrappingTextBoxFlag xmlns="" xmlns:ma14="http://schemas.microsoft.com/office/mac/drawingml/2011/main" val="0"/>
             </a:ext>
           </a:extLst>
         </p:spPr>
@@ -15403,7 +15194,7 @@
           </a:prstGeom>
           <a:extLst>
             <a:ext uri="{C572A759-6A51-4108-AA02-DFA0A04FC94B}">
-              <ma14:wrappingTextBoxFlag xmlns:ma14="http://schemas.microsoft.com/office/mac/drawingml/2011/main" xmlns="" val="0"/>
+              <ma14:wrappingTextBoxFlag xmlns="" xmlns:ma14="http://schemas.microsoft.com/office/mac/drawingml/2011/main" val="0"/>
             </a:ext>
           </a:extLst>
         </p:spPr>
@@ -16254,7 +16045,7 @@
           </a:prstGeom>
           <a:extLst>
             <a:ext uri="{C572A759-6A51-4108-AA02-DFA0A04FC94B}">
-              <ma14:wrappingTextBoxFlag xmlns:ma14="http://schemas.microsoft.com/office/mac/drawingml/2011/main" xmlns="" val="0"/>
+              <ma14:wrappingTextBoxFlag xmlns="" xmlns:ma14="http://schemas.microsoft.com/office/mac/drawingml/2011/main" val="0"/>
             </a:ext>
           </a:extLst>
         </p:spPr>
@@ -17164,7 +16955,7 @@
           </a:prstGeom>
           <a:extLst>
             <a:ext uri="{C572A759-6A51-4108-AA02-DFA0A04FC94B}">
-              <ma14:wrappingTextBoxFlag xmlns:ma14="http://schemas.microsoft.com/office/mac/drawingml/2011/main" xmlns="" val="0"/>
+              <ma14:wrappingTextBoxFlag xmlns="" xmlns:ma14="http://schemas.microsoft.com/office/mac/drawingml/2011/main" val="0"/>
             </a:ext>
           </a:extLst>
         </p:spPr>
@@ -18318,7 +18109,7 @@
           </a:prstGeom>
           <a:extLst>
             <a:ext uri="{C572A759-6A51-4108-AA02-DFA0A04FC94B}">
-              <ma14:wrappingTextBoxFlag xmlns:ma14="http://schemas.microsoft.com/office/mac/drawingml/2011/main" xmlns="" val="0"/>
+              <ma14:wrappingTextBoxFlag xmlns="" xmlns:ma14="http://schemas.microsoft.com/office/mac/drawingml/2011/main" val="0"/>
             </a:ext>
           </a:extLst>
         </p:spPr>
@@ -19831,7 +19622,7 @@
           </a:prstGeom>
           <a:extLst>
             <a:ext uri="{C572A759-6A51-4108-AA02-DFA0A04FC94B}">
-              <ma14:wrappingTextBoxFlag xmlns:ma14="http://schemas.microsoft.com/office/mac/drawingml/2011/main" xmlns="" val="0"/>
+              <ma14:wrappingTextBoxFlag xmlns="" xmlns:ma14="http://schemas.microsoft.com/office/mac/drawingml/2011/main" val="0"/>
             </a:ext>
           </a:extLst>
         </p:spPr>
@@ -20708,7 +20499,7 @@
           </a:prstGeom>
           <a:extLst>
             <a:ext uri="{C572A759-6A51-4108-AA02-DFA0A04FC94B}">
-              <ma14:wrappingTextBoxFlag xmlns:ma14="http://schemas.microsoft.com/office/mac/drawingml/2011/main" xmlns="" val="0"/>
+              <ma14:wrappingTextBoxFlag xmlns="" xmlns:ma14="http://schemas.microsoft.com/office/mac/drawingml/2011/main" val="0"/>
             </a:ext>
           </a:extLst>
         </p:spPr>

</xml_diff>